<commit_message>
Example output presentation corrected
</commit_message>
<xml_diff>
--- a/example-outputs/P_vs_NP_study_guide.pptx
+++ b/example-outputs/P_vs_NP_study_guide.pptx
@@ -19282,8 +19282,8 @@
           <p:nvPr/>
         </p:nvGraphicFramePr>
         <p:xfrm>
-          <a:off x="530352.0" y="4251960"/>
-          <a:ext cx="5336895.5" cy="1536192"/>
+          <a:off x="530352" y="4251960"/>
+          <a:ext cx="5336896" cy="1536192"/>
         </p:xfrm>
         <a:graphic>
           <a:graphicData uri="http://schemas.openxmlformats.org/drawingml/2006/table">
@@ -23215,8 +23215,8 @@
           <p:nvPr/>
         </p:nvGraphicFramePr>
         <p:xfrm>
-          <a:off x="4362602.333333334" y="1828800"/>
-          <a:ext cx="3466490.3333333335" cy="1024128"/>
+          <a:off x="4362602" y="1828800"/>
+          <a:ext cx="3466490" cy="1024128"/>
         </p:xfrm>
         <a:graphic>
           <a:graphicData uri="http://schemas.openxmlformats.org/drawingml/2006/table">

</xml_diff>